<commit_message>
chore(merge_260710): verified SOD/SimCT/SDPO dry-runs + latex/reqs updates
Verified all three merged methods run end-to-end (2 real training steps
each, checkpoints saved) on merge_260710 with the OpenAgentRL-sj env / 8xH20:
- SOD:   Qwen3-1.7B student + DemyAgent-4B teacher, async vLLM V1 multi-turn
- SimCT: Phi-4-mini + Qwen2.5-7B, 8S+8T shared cross-tokenizer (mem 0.35/0.35)
- SDPO:  Qwen3-8B self-distillation (EMA self-teacher, rollout-correction)

Includes simct/losses.py (span mean + contiguous-array fix), matching
test_losses.py update, requirements.txt pin refresh, and latex paper revisions.

AI assistance (Claude) was used for verification and this commit.

Co-authored-by: Claude
</commit_message>
<xml_diff>
--- a/latex/figures/framework_0526.pptx
+++ b/latex/figures/framework_0526.pptx
@@ -3664,7 +3664,7 @@
                 <a:latin typeface="Times New Roman" panose="02020603050405020304" pitchFamily="18" charset="0"/>
                 <a:cs typeface="Times New Roman" panose="02020603050405020304" pitchFamily="18" charset="0"/>
               </a:rPr>
-              <a:t>Unified</a:t>
+              <a:t>OPD Integration</a:t>
             </a:r>
             <a:r>
               <a:rPr lang="zh-CN" altLang="en-US" sz="2200" b="1" dirty="0">
@@ -4875,7 +4875,7 @@
                   <a:latin typeface="Times New Roman" panose="02020603050405020304" pitchFamily="18" charset="0"/>
                   <a:cs typeface="Times New Roman" panose="02020603050405020304" pitchFamily="18" charset="0"/>
                 </a:rPr>
-                <a:t>Unified OPD method library</a:t>
+                <a:t>Released OPD methods</a:t>
               </a:r>
               <a:endParaRPr lang="en" altLang="zh-CN" sz="1400" dirty="0">
                 <a:solidFill>
@@ -5011,7 +5011,7 @@
                   <a:latin typeface="Times New Roman" panose="02020603050405020304" pitchFamily="18" charset="0"/>
                   <a:cs typeface="Times New Roman" panose="02020603050405020304" pitchFamily="18" charset="0"/>
                 </a:rPr>
-                <a:t>MiniLLM</a:t>
+                <a:t/>
               </a:r>
               <a:endParaRPr sz="869" b="1" dirty="0">
                 <a:solidFill>
@@ -5079,7 +5079,7 @@
                   <a:latin typeface="Times New Roman" panose="02020603050405020304" pitchFamily="18" charset="0"/>
                   <a:cs typeface="Times New Roman" panose="02020603050405020304" pitchFamily="18" charset="0"/>
                 </a:rPr>
-                <a:t>OPSD</a:t>
+                <a:t>SDPO</a:t>
               </a:r>
               <a:endParaRPr sz="869" b="1" dirty="0">
                 <a:solidFill>
@@ -5147,7 +5147,7 @@
                   <a:latin typeface="Times New Roman" panose="02020603050405020304" pitchFamily="18" charset="0"/>
                   <a:cs typeface="Times New Roman" panose="02020603050405020304" pitchFamily="18" charset="0"/>
                 </a:rPr>
-                <a:t>SRPO</a:t>
+                <a:t/>
               </a:r>
               <a:endParaRPr sz="869" b="1" dirty="0">
                 <a:solidFill>
@@ -7489,7 +7489,7 @@
                 <a:latin typeface="Times New Roman" panose="02020603050405020304" pitchFamily="18" charset="0"/>
                 <a:cs typeface="Times New Roman" panose="02020603050405020304" pitchFamily="18" charset="0"/>
               </a:rPr>
-              <a:t>Unify OPD methods</a:t>
+              <a:t>Localize method-specific supervision</a:t>
             </a:r>
             <a:r>
               <a:rPr lang="en" sz="1400" dirty="0">
@@ -7782,7 +7782,7 @@
                 </a:solidFill>
                 <a:latin typeface="Aptos"/>
               </a:rPr>
-              <a:t>Switch</a:t>
+              <a:t>Select</a:t>
             </a:r>
             <a:r>
               <a:rPr lang="zh-CN" altLang="en-US" sz="1400" b="1" dirty="0">
@@ -7800,7 +7800,7 @@
                 </a:solidFill>
                 <a:latin typeface="Aptos"/>
               </a:rPr>
-              <a:t>methods</a:t>
+              <a:t>released methods</a:t>
             </a:r>
           </a:p>
           <a:p>
@@ -7812,7 +7812,7 @@
                 </a:solidFill>
                 <a:latin typeface="Aptos"/>
               </a:rPr>
-              <a:t> by</a:t>
+              <a:t> through</a:t>
             </a:r>
             <a:r>
               <a:rPr lang="zh-CN" altLang="en-US" sz="1400" b="1" dirty="0">
@@ -7830,7 +7830,7 @@
                 </a:solidFill>
                 <a:latin typeface="Aptos"/>
               </a:rPr>
-              <a:t>changing YAML only</a:t>
+              <a:t>YAML configurations</a:t>
             </a:r>
             <a:r>
               <a:rPr lang="en-US" altLang="zh-CN" sz="1400" b="1" dirty="0">
@@ -8435,7 +8435,7 @@
                 <a:latin typeface="Times New Roman" panose="02020603050405020304" pitchFamily="18" charset="0"/>
                 <a:cs typeface="Times New Roman" panose="02020603050405020304" pitchFamily="18" charset="0"/>
               </a:rPr>
-              <a:t>Preserve </a:t>
+              <a:t>Reuse </a:t>
             </a:r>
             <a:r>
               <a:rPr lang="en" altLang="zh-CN" sz="1200" b="1" dirty="0" err="1">
@@ -8455,7 +8455,7 @@
                 <a:latin typeface="Times New Roman" panose="02020603050405020304" pitchFamily="18" charset="0"/>
                 <a:cs typeface="Times New Roman" panose="02020603050405020304" pitchFamily="18" charset="0"/>
               </a:rPr>
-              <a:t> as the stable execution substrate</a:t>
+              <a:t> for rollout, optimization, and distributed execution</a:t>
             </a:r>
           </a:p>
         </p:txBody>

</xml_diff>